<commit_message>
batch: 320/565 gemeenten (tussentijds)
</commit_message>
<xml_diff>
--- a/Fluctus_Laadplan_Bergen.pptx
+++ b/Fluctus_Laadplan_Bergen.pptx
@@ -118,7 +118,7 @@
 </p:presentation>
 </file>
 
-<file path=ppt/charts/chart310.xml><?xml version="1.0" encoding="utf-8"?>
+<file path=ppt/charts/chart311.xml><?xml version="1.0" encoding="utf-8"?>
 <c:chartSpace xmlns:c="http://schemas.openxmlformats.org/drawingml/2006/chart" xmlns:a="http://schemas.openxmlformats.org/drawingml/2006/main" xmlns:r="http://schemas.openxmlformats.org/officeDocument/2006/relationships">
   <c:date1904 val="0"/>
   <c:roundedCorners val="1"/>
@@ -16436,7 +16436,7 @@
         </p:nvSpPr>
         <p:spPr>
           <a:xfrm>
-            <a:off x="897383" y="2212467"/>
+            <a:off x="897375" y="2212458"/>
             <a:ext cx="384048" cy="384048"/>
           </a:xfrm>
           <a:prstGeom prst="ellipse">
@@ -16461,7 +16461,7 @@
         </p:nvSpPr>
         <p:spPr>
           <a:xfrm>
-            <a:off x="897383" y="2212467"/>
+            <a:off x="897375" y="2212458"/>
             <a:ext cx="384048" cy="384048"/>
           </a:xfrm>
           <a:prstGeom prst="rect">
@@ -17299,7 +17299,46 @@
       </p:sp>
       <p:sp>
         <p:nvSpPr>
-          <p:cNvPr id="275" name="Shape 273"/>
+          <p:cNvPr id="275" name="Text 273"/>
+          <p:cNvSpPr/>
+          <p:nvPr/>
+        </p:nvSpPr>
+        <p:spPr>
+          <a:xfrm>
+            <a:off x="640080" y="6071616"/>
+            <a:ext cx="10058400" cy="237744"/>
+          </a:xfrm>
+          <a:prstGeom prst="rect">
+            <a:avLst/>
+          </a:prstGeom>
+          <a:noFill/>
+          <a:ln/>
+        </p:spPr>
+        <p:txBody>
+          <a:bodyPr wrap="square" lIns="0" tIns="0" rIns="0" bIns="0" rtlCol="0" anchor="ctr"/>
+          <a:lstStyle/>
+          <a:p>
+            <a:pPr indent="0" marL="0">
+              <a:buNone/>
+            </a:pPr>
+            <a:r>
+              <a:rPr lang="en-US" sz="800" i="1" dirty="0">
+                <a:solidFill>
+                  <a:srgbClr val="5A6473"/>
+                </a:solidFill>
+                <a:latin typeface="Arial" pitchFamily="34" charset="0"/>
+                <a:ea typeface="Arial" pitchFamily="34" charset="-122"/>
+                <a:cs typeface="Arial" pitchFamily="34" charset="-120"/>
+              </a:rPr>
+              <a:t>Bron bestaande laadpunten: Departement Mobiliteit en Openbare Werken (Vlaanderen).</a:t>
+            </a:r>
+            <a:endParaRPr lang="en-US" sz="800" dirty="0"/>
+          </a:p>
+        </p:txBody>
+      </p:sp>
+      <p:sp>
+        <p:nvSpPr>
+          <p:cNvPr id="276" name="Shape 274"/>
           <p:cNvSpPr/>
           <p:nvPr/>
         </p:nvSpPr>
@@ -17319,7 +17358,7 @@
       </p:sp>
       <p:pic>
         <p:nvPicPr>
-          <p:cNvPr id="276" name="Image 0" descr="preencoded.png">    </p:cNvPr>
+          <p:cNvPr id="277" name="Image 0" descr="preencoded.png">    </p:cNvPr>
           <p:cNvPicPr>
             <a:picLocks noChangeAspect="1"/>
           </p:cNvPicPr>
@@ -17343,7 +17382,7 @@
       </p:pic>
       <p:sp>
         <p:nvSpPr>
-          <p:cNvPr id="277" name="Text 274"/>
+          <p:cNvPr id="278" name="Text 275"/>
           <p:cNvSpPr/>
           <p:nvPr/>
         </p:nvSpPr>
@@ -17385,7 +17424,7 @@
       </p:sp>
       <p:sp>
         <p:nvSpPr>
-          <p:cNvPr id="278" name="Shape 275"/>
+          <p:cNvPr id="279" name="Shape 276"/>
           <p:cNvSpPr/>
           <p:nvPr/>
         </p:nvSpPr>
@@ -17405,7 +17444,7 @@
       </p:sp>
       <p:pic>
         <p:nvPicPr>
-          <p:cNvPr id="279" name="Image 1" descr="preencoded.png">    </p:cNvPr>
+          <p:cNvPr id="280" name="Image 1" descr="preencoded.png">    </p:cNvPr>
           <p:cNvPicPr>
             <a:picLocks noChangeAspect="1"/>
           </p:cNvPicPr>
@@ -17429,7 +17468,7 @@
       </p:pic>
       <p:sp>
         <p:nvSpPr>
-          <p:cNvPr id="280" name="Text 276"/>
+          <p:cNvPr id="281" name="Text 277"/>
           <p:cNvSpPr/>
           <p:nvPr/>
         </p:nvSpPr>
@@ -17471,7 +17510,7 @@
       </p:sp>
       <p:sp>
         <p:nvSpPr>
-          <p:cNvPr id="281" name="Shape 277"/>
+          <p:cNvPr id="282" name="Shape 278"/>
           <p:cNvSpPr/>
           <p:nvPr/>
         </p:nvSpPr>
@@ -17491,7 +17530,7 @@
       </p:sp>
       <p:pic>
         <p:nvPicPr>
-          <p:cNvPr id="282" name="Image 2" descr="preencoded.png">    </p:cNvPr>
+          <p:cNvPr id="283" name="Image 2" descr="preencoded.png">    </p:cNvPr>
           <p:cNvPicPr>
             <a:picLocks noChangeAspect="1"/>
           </p:cNvPicPr>
@@ -17515,7 +17554,7 @@
       </p:pic>
       <p:sp>
         <p:nvSpPr>
-          <p:cNvPr id="283" name="Text 278"/>
+          <p:cNvPr id="284" name="Text 279"/>
           <p:cNvSpPr/>
           <p:nvPr/>
         </p:nvSpPr>
@@ -17557,7 +17596,7 @@
       </p:sp>
       <p:sp>
         <p:nvSpPr>
-          <p:cNvPr id="284" name="Text 279"/>
+          <p:cNvPr id="285" name="Text 280"/>
           <p:cNvSpPr/>
           <p:nvPr/>
         </p:nvSpPr>
@@ -17596,7 +17635,7 @@
       </p:sp>
       <p:sp>
         <p:nvSpPr>
-          <p:cNvPr id="285" name="Text 280"/>
+          <p:cNvPr id="286" name="Text 281"/>
           <p:cNvSpPr/>
           <p:nvPr/>
         </p:nvSpPr>

</xml_diff>